<commit_message>
Publish Arc final submission on Cloudflare Workers
</commit_message>
<xml_diff>
--- a/docs/deck.pptx
+++ b/docs/deck.pptx
@@ -2,20 +2,20 @@
 <file path=ppt/presentation.xml><?xml version="1.0" encoding="utf-8"?>
 <p:presentation xmlns:p="http://schemas.openxmlformats.org/presentationml/2006/main">
   <p:sldMasterIdLst>
-    <p:sldMasterId xmlns:r="http://schemas.openxmlformats.org/officeDocument/2006/relationships" id="2147483648" r:id="Rb26f9d0eaf4146c0"/>
+    <p:sldMasterId xmlns:r="http://schemas.openxmlformats.org/officeDocument/2006/relationships" id="2147483648" r:id="Rcbd19ca207aa4169"/>
   </p:sldMasterIdLst>
   <p:notesMasterIdLst>
-    <p:notesMasterId xmlns:r="http://schemas.openxmlformats.org/officeDocument/2006/relationships" r:id="R80cc1bf961574772"/>
+    <p:notesMasterId xmlns:r="http://schemas.openxmlformats.org/officeDocument/2006/relationships" r:id="Re9e92a3b6d524abd"/>
   </p:notesMasterIdLst>
   <p:sldIdLst>
-    <p:sldId xmlns:r="http://schemas.openxmlformats.org/officeDocument/2006/relationships" id="256" r:id="Rcd9f7e98e6244a14"/>
-    <p:sldId xmlns:r="http://schemas.openxmlformats.org/officeDocument/2006/relationships" id="257" r:id="R694a1f7705e04404"/>
-    <p:sldId xmlns:r="http://schemas.openxmlformats.org/officeDocument/2006/relationships" id="258" r:id="Recf9a306106749e6"/>
-    <p:sldId xmlns:r="http://schemas.openxmlformats.org/officeDocument/2006/relationships" id="259" r:id="R67ad5abbd0eb4ce4"/>
-    <p:sldId xmlns:r="http://schemas.openxmlformats.org/officeDocument/2006/relationships" id="260" r:id="Rd4ecb8c2ca2c4e3c"/>
-    <p:sldId xmlns:r="http://schemas.openxmlformats.org/officeDocument/2006/relationships" id="261" r:id="R091a09beb4744ea5"/>
-    <p:sldId xmlns:r="http://schemas.openxmlformats.org/officeDocument/2006/relationships" id="262" r:id="Rd65926c527e14e50"/>
-    <p:sldId xmlns:r="http://schemas.openxmlformats.org/officeDocument/2006/relationships" id="263" r:id="Rd69ac01f4c344b36"/>
+    <p:sldId xmlns:r="http://schemas.openxmlformats.org/officeDocument/2006/relationships" id="256" r:id="R7d4a18ad27f943cf"/>
+    <p:sldId xmlns:r="http://schemas.openxmlformats.org/officeDocument/2006/relationships" id="257" r:id="R9f535ca978234bee"/>
+    <p:sldId xmlns:r="http://schemas.openxmlformats.org/officeDocument/2006/relationships" id="258" r:id="R748aa1b5e3254433"/>
+    <p:sldId xmlns:r="http://schemas.openxmlformats.org/officeDocument/2006/relationships" id="259" r:id="R8ff6c089435b4085"/>
+    <p:sldId xmlns:r="http://schemas.openxmlformats.org/officeDocument/2006/relationships" id="260" r:id="Rb7b86855cbae4d7a"/>
+    <p:sldId xmlns:r="http://schemas.openxmlformats.org/officeDocument/2006/relationships" id="261" r:id="Rc567bd566eca4e46"/>
+    <p:sldId xmlns:r="http://schemas.openxmlformats.org/officeDocument/2006/relationships" id="262" r:id="R1ab0a7824ee4483b"/>
+    <p:sldId xmlns:r="http://schemas.openxmlformats.org/officeDocument/2006/relationships" id="263" r:id="R18ce036de2ca4122"/>
   </p:sldIdLst>
   <p:sldSz cx="12192000" cy="6858000"/>
   <p:notesSz cx="6858000" cy="9144000"/>
@@ -954,7 +954,7 @@
           </a:p>
           <a:p xmlns:a="http://schemas.openxmlformats.org/drawingml/2006/main">
             <a:r>
-              <a:t>- https://radar-agent-arc-2026.chrischang2026.chatgpt.site</a:t>
+              <a:t>- https://radar-agent-arc-2026.chrischang2026.workers.dev</a:t>
             </a:r>
           </a:p>
           <a:p xmlns:a="http://schemas.openxmlformats.org/drawingml/2006/main">
@@ -1034,7 +1034,7 @@
           </a:p>
           <a:p xmlns:a="http://schemas.openxmlformats.org/drawingml/2006/main">
             <a:r>
-              <a:t>- https://radar-agent-arc-2026.chrischang2026.chatgpt.site</a:t>
+              <a:t>- https://radar-agent-arc-2026.chrischang2026.workers.dev</a:t>
             </a:r>
           </a:p>
           <a:p xmlns:a="http://schemas.openxmlformats.org/drawingml/2006/main">
@@ -1117,7 +1117,7 @@
   </p:cSld>
   <p:clrMap bg1="lt1" tx1="dk1" bg2="lt2" tx2="dk2" accent1="accent1" accent2="accent2" accent3="accent3" accent4="accent4" accent5="accent5" accent6="accent6" hlink="hlink" folHlink="folHlink"/>
   <p:sldLayoutIdLst>
-    <p:sldLayoutId xmlns:r="http://schemas.openxmlformats.org/officeDocument/2006/relationships" id="2147483649" r:id="Rb8103ce5ac494720"/>
+    <p:sldLayoutId xmlns:r="http://schemas.openxmlformats.org/officeDocument/2006/relationships" id="2147483649" r:id="R65136428b9fe490d"/>
   </p:sldLayoutIdLst>
   <p:txStyles>
     <p:titleStyle>
@@ -1661,7 +1661,7 @@
           <p:cNvPr id="10" name="Google-Shape-532-p58-2">
             <a:extLst xmlns:a="http://schemas.openxmlformats.org/drawingml/2006/main">
               <a:ext uri="{FF2B5EF4-FFF2-40B4-BE49-F238E27FC236}">
-                <a16:creationId xmlns:a16="http://schemas.microsoft.com/office/drawing/2014/main" id="{DB1D703A-761D-4132-AEBF-23D15A227255}"/>
+                <a16:creationId xmlns:a16="http://schemas.microsoft.com/office/drawing/2014/main" id="{75F89CF8-D038-4CC7-8465-C7C867E00590}"/>
               </a:ext>
             </a:extLst>
           </p:cNvPr>
@@ -1706,7 +1706,7 @@
           <p:cNvPr id="2" name="Google-Shape-533-p58-3">
             <a:extLst xmlns:a="http://schemas.openxmlformats.org/drawingml/2006/main">
               <a:ext uri="{FF2B5EF4-FFF2-40B4-BE49-F238E27FC236}">
-                <a16:creationId xmlns:a16="http://schemas.microsoft.com/office/drawing/2014/main" id="{CF437B4D-F93D-4BAE-816F-184C7A78ACE5}"/>
+                <a16:creationId xmlns:a16="http://schemas.microsoft.com/office/drawing/2014/main" id="{0CEEC9C2-BC32-4C06-A428-5264408B6522}"/>
               </a:ext>
             </a:extLst>
           </p:cNvPr>
@@ -1751,7 +1751,7 @@
           <p:cNvPr id="3" name="Picture-3-4-backing">
             <a:extLst xmlns:a="http://schemas.openxmlformats.org/drawingml/2006/main">
               <a:ext uri="{FF2B5EF4-FFF2-40B4-BE49-F238E27FC236}">
-                <a16:creationId xmlns:a16="http://schemas.microsoft.com/office/drawing/2014/main" id="{906568AC-11D4-4181-88A6-548D4BEA4E5E}"/>
+                <a16:creationId xmlns:a16="http://schemas.microsoft.com/office/drawing/2014/main" id="{75D8EFF6-51BB-44F7-8202-60C34667CCDC}"/>
               </a:ext>
             </a:extLst>
           </p:cNvPr>
@@ -1786,7 +1786,7 @@
           <p:cNvPr id="5" name="Google-Shape-534-p58-5">
             <a:extLst xmlns:a="http://schemas.openxmlformats.org/drawingml/2006/main">
               <a:ext uri="{FF2B5EF4-FFF2-40B4-BE49-F238E27FC236}">
-                <a16:creationId xmlns:a16="http://schemas.microsoft.com/office/drawing/2014/main" id="{E89DAFA4-095C-4CF7-8396-90BE6C5808EA}"/>
+                <a16:creationId xmlns:a16="http://schemas.microsoft.com/office/drawing/2014/main" id="{02D6A797-60D6-42B7-A5CD-114C4B4C794F}"/>
               </a:ext>
             </a:extLst>
           </p:cNvPr>
@@ -1846,7 +1846,7 @@
           <p:cNvPr id="6" name="cover-title">
             <a:extLst xmlns:a="http://schemas.openxmlformats.org/drawingml/2006/main">
               <a:ext uri="{FF2B5EF4-FFF2-40B4-BE49-F238E27FC236}">
-                <a16:creationId xmlns:a16="http://schemas.microsoft.com/office/drawing/2014/main" id="{FD775B51-2A59-4C88-AB18-157380B07B3F}"/>
+                <a16:creationId xmlns:a16="http://schemas.microsoft.com/office/drawing/2014/main" id="{479FF634-6BD9-46EE-AC0A-BA85A7860CB1}"/>
               </a:ext>
             </a:extLst>
           </p:cNvPr>
@@ -1902,7 +1902,7 @@
           <p:cNvPr id="7" name="cover-subtitle">
             <a:extLst xmlns:a="http://schemas.openxmlformats.org/drawingml/2006/main">
               <a:ext uri="{FF2B5EF4-FFF2-40B4-BE49-F238E27FC236}">
-                <a16:creationId xmlns:a16="http://schemas.microsoft.com/office/drawing/2014/main" id="{31B5F47A-1591-45A4-A462-11A9AACFD023}"/>
+                <a16:creationId xmlns:a16="http://schemas.microsoft.com/office/drawing/2014/main" id="{958EC002-8521-4EF8-A063-21B7F0CBB507}"/>
               </a:ext>
             </a:extLst>
           </p:cNvPr>
@@ -1958,7 +1958,7 @@
           <p:cNvPr id="8" name="cover-meta">
             <a:extLst xmlns:a="http://schemas.openxmlformats.org/drawingml/2006/main">
               <a:ext uri="{FF2B5EF4-FFF2-40B4-BE49-F238E27FC236}">
-                <a16:creationId xmlns:a16="http://schemas.microsoft.com/office/drawing/2014/main" id="{30CFCBC5-4ED7-45E3-92AB-48FEB42DABDA}"/>
+                <a16:creationId xmlns:a16="http://schemas.microsoft.com/office/drawing/2014/main" id="{5E1A71BC-197F-4BAD-B33C-EED006D0C605}"/>
               </a:ext>
             </a:extLst>
           </p:cNvPr>
@@ -2018,7 +2018,7 @@
           <p:nvPr/>
         </p:nvPicPr>
         <p:blipFill>
-          <a:blip xmlns:r="http://schemas.openxmlformats.org/officeDocument/2006/relationships" xmlns:a="http://schemas.openxmlformats.org/drawingml/2006/main" r:embed="R4ae9779261894bbc"/>
+          <a:blip xmlns:r="http://schemas.openxmlformats.org/officeDocument/2006/relationships" xmlns:a="http://schemas.openxmlformats.org/drawingml/2006/main" r:embed="R23b6bdced70b415e"/>
           <a:stretch xmlns:a="http://schemas.openxmlformats.org/drawingml/2006/main"/>
         </p:blipFill>
         <p:spPr>
@@ -2036,7 +2036,7 @@
     </p:spTree>
     <p:extLst>
       <p:ext uri="{BB962C8B-B14F-4D97-AF65-F5344CB8AC3E}">
-        <p14:creationId xmlns:p14="http://schemas.microsoft.com/office/powerpoint/2010/main" val="1855655301"/>
+        <p14:creationId xmlns:p14="http://schemas.microsoft.com/office/powerpoint/2010/main" val="697499025"/>
       </p:ext>
     </p:extLst>
   </p:cSld>
@@ -2060,7 +2060,7 @@
           <p:cNvPr id="15" name="Google-Shape-532-p58-2">
             <a:extLst xmlns:a="http://schemas.openxmlformats.org/drawingml/2006/main">
               <a:ext uri="{FF2B5EF4-FFF2-40B4-BE49-F238E27FC236}">
-                <a16:creationId xmlns:a16="http://schemas.microsoft.com/office/drawing/2014/main" id="{96FC2171-5B7E-4C15-95B4-9905FBB65BA3}"/>
+                <a16:creationId xmlns:a16="http://schemas.microsoft.com/office/drawing/2014/main" id="{AB920F17-F0CC-40E7-8755-9D555297839D}"/>
               </a:ext>
             </a:extLst>
           </p:cNvPr>
@@ -2105,7 +2105,7 @@
           <p:cNvPr id="2" name="Google-Shape-533-p58-3">
             <a:extLst xmlns:a="http://schemas.openxmlformats.org/drawingml/2006/main">
               <a:ext uri="{FF2B5EF4-FFF2-40B4-BE49-F238E27FC236}">
-                <a16:creationId xmlns:a16="http://schemas.microsoft.com/office/drawing/2014/main" id="{2B3C327D-339A-4DA9-8F6A-98266272E64F}"/>
+                <a16:creationId xmlns:a16="http://schemas.microsoft.com/office/drawing/2014/main" id="{B92336E6-C85F-402F-85C7-171E03FCE8DB}"/>
               </a:ext>
             </a:extLst>
           </p:cNvPr>
@@ -2150,7 +2150,7 @@
           <p:cNvPr id="3" name="Google-Shape-534-p58-4">
             <a:extLst xmlns:a="http://schemas.openxmlformats.org/drawingml/2006/main">
               <a:ext uri="{FF2B5EF4-FFF2-40B4-BE49-F238E27FC236}">
-                <a16:creationId xmlns:a16="http://schemas.microsoft.com/office/drawing/2014/main" id="{4409F4D3-5BE2-4254-98D2-A54F0297E268}"/>
+                <a16:creationId xmlns:a16="http://schemas.microsoft.com/office/drawing/2014/main" id="{B58323DB-4861-454D-94FA-10E1C4C4381F}"/>
               </a:ext>
             </a:extLst>
           </p:cNvPr>
@@ -2195,7 +2195,7 @@
           <p:cNvPr id="4" name="Content-Placeholder-10-5">
             <a:extLst xmlns:a="http://schemas.openxmlformats.org/drawingml/2006/main">
               <a:ext uri="{FF2B5EF4-FFF2-40B4-BE49-F238E27FC236}">
-                <a16:creationId xmlns:a16="http://schemas.microsoft.com/office/drawing/2014/main" id="{05EA25C0-E85E-4B06-B2A8-E75356B8E694}"/>
+                <a16:creationId xmlns:a16="http://schemas.microsoft.com/office/drawing/2014/main" id="{C0268509-E5E1-4919-A869-46D0C0A3642C}"/>
               </a:ext>
             </a:extLst>
           </p:cNvPr>
@@ -2240,7 +2240,7 @@
           <p:cNvPr id="5" name="Google-Shape-340-p61-6">
             <a:extLst xmlns:a="http://schemas.openxmlformats.org/drawingml/2006/main">
               <a:ext uri="{FF2B5EF4-FFF2-40B4-BE49-F238E27FC236}">
-                <a16:creationId xmlns:a16="http://schemas.microsoft.com/office/drawing/2014/main" id="{BAF733E2-FC5A-4339-818D-35F4759BEC53}"/>
+                <a16:creationId xmlns:a16="http://schemas.microsoft.com/office/drawing/2014/main" id="{B2402430-A7DE-4A38-B9F4-324456FC0920}"/>
               </a:ext>
             </a:extLst>
           </p:cNvPr>
@@ -2364,7 +2364,7 @@
           <p:cNvPr id="6" name="TextBox-11-7">
             <a:extLst xmlns:a="http://schemas.openxmlformats.org/drawingml/2006/main">
               <a:ext uri="{FF2B5EF4-FFF2-40B4-BE49-F238E27FC236}">
-                <a16:creationId xmlns:a16="http://schemas.microsoft.com/office/drawing/2014/main" id="{144C1F6A-DF44-4EC1-999A-B72A8B08909E}"/>
+                <a16:creationId xmlns:a16="http://schemas.microsoft.com/office/drawing/2014/main" id="{28CC711E-3D0F-4A97-91CD-09F5CB1C7F38}"/>
               </a:ext>
             </a:extLst>
           </p:cNvPr>
@@ -2424,7 +2424,7 @@
           <p:cNvPr id="7" name="Content-Placeholder-10-8">
             <a:extLst xmlns:a="http://schemas.openxmlformats.org/drawingml/2006/main">
               <a:ext uri="{FF2B5EF4-FFF2-40B4-BE49-F238E27FC236}">
-                <a16:creationId xmlns:a16="http://schemas.microsoft.com/office/drawing/2014/main" id="{12DC5FD4-A6E7-4E65-9631-E24652C9BFC8}"/>
+                <a16:creationId xmlns:a16="http://schemas.microsoft.com/office/drawing/2014/main" id="{16284AA1-9056-4A7E-95F9-D6281F61C200}"/>
               </a:ext>
             </a:extLst>
           </p:cNvPr>
@@ -2469,7 +2469,7 @@
           <p:cNvPr id="8" name="Google-Shape-340-p61-9">
             <a:extLst xmlns:a="http://schemas.openxmlformats.org/drawingml/2006/main">
               <a:ext uri="{FF2B5EF4-FFF2-40B4-BE49-F238E27FC236}">
-                <a16:creationId xmlns:a16="http://schemas.microsoft.com/office/drawing/2014/main" id="{BD0A3177-5F5C-48B9-8D67-C960C30E328D}"/>
+                <a16:creationId xmlns:a16="http://schemas.microsoft.com/office/drawing/2014/main" id="{C7824DAD-21EB-4B2D-8642-E23EFF4E37F6}"/>
               </a:ext>
             </a:extLst>
           </p:cNvPr>
@@ -2593,7 +2593,7 @@
           <p:cNvPr id="9" name="Content-Placeholder-10-10">
             <a:extLst xmlns:a="http://schemas.openxmlformats.org/drawingml/2006/main">
               <a:ext uri="{FF2B5EF4-FFF2-40B4-BE49-F238E27FC236}">
-                <a16:creationId xmlns:a16="http://schemas.microsoft.com/office/drawing/2014/main" id="{C4DF127C-5348-43B1-AE9C-7008F57DBF58}"/>
+                <a16:creationId xmlns:a16="http://schemas.microsoft.com/office/drawing/2014/main" id="{D2C36AB0-91A2-4BBB-82D5-8C1BFF7608BE}"/>
               </a:ext>
             </a:extLst>
           </p:cNvPr>
@@ -2638,7 +2638,7 @@
           <p:cNvPr id="10" name="Google-Shape-340-p61-11">
             <a:extLst xmlns:a="http://schemas.openxmlformats.org/drawingml/2006/main">
               <a:ext uri="{FF2B5EF4-FFF2-40B4-BE49-F238E27FC236}">
-                <a16:creationId xmlns:a16="http://schemas.microsoft.com/office/drawing/2014/main" id="{A355FA4C-97EC-41E0-8FD9-4A177AA8975A}"/>
+                <a16:creationId xmlns:a16="http://schemas.microsoft.com/office/drawing/2014/main" id="{33B5E5A2-92B2-488D-BA9A-1A4D141FFB77}"/>
               </a:ext>
             </a:extLst>
           </p:cNvPr>
@@ -2762,7 +2762,7 @@
           <p:cNvPr id="11" name="Content-Placeholder-10-12">
             <a:extLst xmlns:a="http://schemas.openxmlformats.org/drawingml/2006/main">
               <a:ext uri="{FF2B5EF4-FFF2-40B4-BE49-F238E27FC236}">
-                <a16:creationId xmlns:a16="http://schemas.microsoft.com/office/drawing/2014/main" id="{25AA8A7D-BDBA-482B-B48A-CF7FB4A32024}"/>
+                <a16:creationId xmlns:a16="http://schemas.microsoft.com/office/drawing/2014/main" id="{78764422-6797-414D-BBDE-4CC62C3F58E9}"/>
               </a:ext>
             </a:extLst>
           </p:cNvPr>
@@ -2807,7 +2807,7 @@
           <p:cNvPr id="12" name="Google-Shape-340-p61-13">
             <a:extLst xmlns:a="http://schemas.openxmlformats.org/drawingml/2006/main">
               <a:ext uri="{FF2B5EF4-FFF2-40B4-BE49-F238E27FC236}">
-                <a16:creationId xmlns:a16="http://schemas.microsoft.com/office/drawing/2014/main" id="{BCAE0624-177A-4CC4-8091-0FA4F721388A}"/>
+                <a16:creationId xmlns:a16="http://schemas.microsoft.com/office/drawing/2014/main" id="{ECB41FE0-CA94-41AB-BB12-C617F75CBAB7}"/>
               </a:ext>
             </a:extLst>
           </p:cNvPr>
@@ -2931,7 +2931,7 @@
           <p:cNvPr id="13" name="Content-Placeholder-10-14">
             <a:extLst xmlns:a="http://schemas.openxmlformats.org/drawingml/2006/main">
               <a:ext uri="{FF2B5EF4-FFF2-40B4-BE49-F238E27FC236}">
-                <a16:creationId xmlns:a16="http://schemas.microsoft.com/office/drawing/2014/main" id="{EEC7CA61-44DF-41AC-90EA-1D9B3B7C315B}"/>
+                <a16:creationId xmlns:a16="http://schemas.microsoft.com/office/drawing/2014/main" id="{D394B249-8227-4BAB-BE0B-4D4E61B38E4C}"/>
               </a:ext>
             </a:extLst>
           </p:cNvPr>
@@ -2976,7 +2976,7 @@
           <p:cNvPr id="14" name="Google-Shape-340-p61-15">
             <a:extLst xmlns:a="http://schemas.openxmlformats.org/drawingml/2006/main">
               <a:ext uri="{FF2B5EF4-FFF2-40B4-BE49-F238E27FC236}">
-                <a16:creationId xmlns:a16="http://schemas.microsoft.com/office/drawing/2014/main" id="{3747A8D4-07C3-4B01-920D-C74851846A97}"/>
+                <a16:creationId xmlns:a16="http://schemas.microsoft.com/office/drawing/2014/main" id="{69672FE3-F7BE-480C-B437-605FFA5EA36D}"/>
               </a:ext>
             </a:extLst>
           </p:cNvPr>
@@ -3098,7 +3098,7 @@
     </p:spTree>
     <p:extLst>
       <p:ext uri="{BB962C8B-B14F-4D97-AF65-F5344CB8AC3E}">
-        <p14:creationId xmlns:p14="http://schemas.microsoft.com/office/powerpoint/2010/main" val="689299777"/>
+        <p14:creationId xmlns:p14="http://schemas.microsoft.com/office/powerpoint/2010/main" val="2146295557"/>
       </p:ext>
     </p:extLst>
   </p:cSld>
@@ -3122,7 +3122,7 @@
           <p:cNvPr id="13" name="Slide-Number-Placeholder-3-2">
             <a:extLst xmlns:a="http://schemas.openxmlformats.org/drawingml/2006/main">
               <a:ext uri="{FF2B5EF4-FFF2-40B4-BE49-F238E27FC236}">
-                <a16:creationId xmlns:a16="http://schemas.microsoft.com/office/drawing/2014/main" id="{B79A56DA-5CF5-4CE2-A508-E83319AF6E8F}"/>
+                <a16:creationId xmlns:a16="http://schemas.microsoft.com/office/drawing/2014/main" id="{9B9B3931-1DEE-4065-933A-5A53FE0E7534}"/>
               </a:ext>
             </a:extLst>
           </p:cNvPr>
@@ -3165,7 +3165,7 @@
           <p:cNvPr id="2" name="Title-10-3">
             <a:extLst xmlns:a="http://schemas.openxmlformats.org/drawingml/2006/main">
               <a:ext uri="{FF2B5EF4-FFF2-40B4-BE49-F238E27FC236}">
-                <a16:creationId xmlns:a16="http://schemas.microsoft.com/office/drawing/2014/main" id="{F79B5FE4-F6B3-4856-8E6A-7D400A3FEFCF}"/>
+                <a16:creationId xmlns:a16="http://schemas.microsoft.com/office/drawing/2014/main" id="{FDCE5663-C749-4F15-A575-4AE333369D66}"/>
               </a:ext>
             </a:extLst>
           </p:cNvPr>
@@ -3232,7 +3232,7 @@
           <p:cNvPr id="4" name="Google-Shape-2260-p159-5">
             <a:extLst xmlns:a="http://schemas.openxmlformats.org/drawingml/2006/main">
               <a:ext uri="{FF2B5EF4-FFF2-40B4-BE49-F238E27FC236}">
-                <a16:creationId xmlns:a16="http://schemas.microsoft.com/office/drawing/2014/main" id="{8EA3034F-1820-4815-A805-0BC8A2925A09}"/>
+                <a16:creationId xmlns:a16="http://schemas.microsoft.com/office/drawing/2014/main" id="{8F8BDBEF-4113-4A40-8455-087EDF976F20}"/>
               </a:ext>
             </a:extLst>
           </p:cNvPr>
@@ -3259,7 +3259,7 @@
           <p:cNvPr id="5" name="Google-Shape-2261-p159-6">
             <a:extLst xmlns:a="http://schemas.openxmlformats.org/drawingml/2006/main">
               <a:ext uri="{FF2B5EF4-FFF2-40B4-BE49-F238E27FC236}">
-                <a16:creationId xmlns:a16="http://schemas.microsoft.com/office/drawing/2014/main" id="{6629A474-F669-4AD8-9AD3-254E75E37868}"/>
+                <a16:creationId xmlns:a16="http://schemas.microsoft.com/office/drawing/2014/main" id="{8437B2BF-D1A7-4A79-9FE8-A5E38ADC75B5}"/>
               </a:ext>
             </a:extLst>
           </p:cNvPr>
@@ -3286,7 +3286,7 @@
           <p:cNvPr id="6" name="Google-Shape-2262-p159-7">
             <a:extLst xmlns:a="http://schemas.openxmlformats.org/drawingml/2006/main">
               <a:ext uri="{FF2B5EF4-FFF2-40B4-BE49-F238E27FC236}">
-                <a16:creationId xmlns:a16="http://schemas.microsoft.com/office/drawing/2014/main" id="{610086CD-A711-4BA1-BD0A-EC0AC094A39B}"/>
+                <a16:creationId xmlns:a16="http://schemas.microsoft.com/office/drawing/2014/main" id="{DD9FF5DF-CE66-4399-894C-BF129B46C862}"/>
               </a:ext>
             </a:extLst>
           </p:cNvPr>
@@ -3313,7 +3313,7 @@
           <p:cNvPr id="7" name="Content-Placeholder-15-8">
             <a:extLst xmlns:a="http://schemas.openxmlformats.org/drawingml/2006/main">
               <a:ext uri="{FF2B5EF4-FFF2-40B4-BE49-F238E27FC236}">
-                <a16:creationId xmlns:a16="http://schemas.microsoft.com/office/drawing/2014/main" id="{0D8295F0-FCDF-4903-8F48-8C2437EF4F12}"/>
+                <a16:creationId xmlns:a16="http://schemas.microsoft.com/office/drawing/2014/main" id="{8FBA9670-7B63-41E8-8D56-D942E6919B3A}"/>
               </a:ext>
             </a:extLst>
           </p:cNvPr>
@@ -3358,7 +3358,7 @@
           <p:cNvPr id="8" name="Content-Placeholder-15-9">
             <a:extLst xmlns:a="http://schemas.openxmlformats.org/drawingml/2006/main">
               <a:ext uri="{FF2B5EF4-FFF2-40B4-BE49-F238E27FC236}">
-                <a16:creationId xmlns:a16="http://schemas.microsoft.com/office/drawing/2014/main" id="{A19FE7A2-2924-463F-B887-C4690F17A82C}"/>
+                <a16:creationId xmlns:a16="http://schemas.microsoft.com/office/drawing/2014/main" id="{D9DB4FEE-AE2E-47C8-93F3-3A4EF3857822}"/>
               </a:ext>
             </a:extLst>
           </p:cNvPr>
@@ -3403,7 +3403,7 @@
           <p:cNvPr id="9" name="Content-Placeholder-15-10">
             <a:extLst xmlns:a="http://schemas.openxmlformats.org/drawingml/2006/main">
               <a:ext uri="{FF2B5EF4-FFF2-40B4-BE49-F238E27FC236}">
-                <a16:creationId xmlns:a16="http://schemas.microsoft.com/office/drawing/2014/main" id="{DDBA9B83-2BC5-454F-94DE-4DBF8AD79F8F}"/>
+                <a16:creationId xmlns:a16="http://schemas.microsoft.com/office/drawing/2014/main" id="{C52E04D8-2CF9-4023-BBE0-8B6157D24D0B}"/>
               </a:ext>
             </a:extLst>
           </p:cNvPr>
@@ -3448,7 +3448,7 @@
           <p:cNvPr id="10" name="Text-Placeholder-16-11">
             <a:extLst xmlns:a="http://schemas.openxmlformats.org/drawingml/2006/main">
               <a:ext uri="{FF2B5EF4-FFF2-40B4-BE49-F238E27FC236}">
-                <a16:creationId xmlns:a16="http://schemas.microsoft.com/office/drawing/2014/main" id="{F82C4615-9732-4BAA-98CE-F8BA9C39A7CD}"/>
+                <a16:creationId xmlns:a16="http://schemas.microsoft.com/office/drawing/2014/main" id="{C207DA8E-5033-44BD-A7FF-3EA43FA8896C}"/>
               </a:ext>
             </a:extLst>
           </p:cNvPr>
@@ -3508,7 +3508,7 @@
           <p:cNvPr id="11" name="Text-Placeholder-16-12">
             <a:extLst xmlns:a="http://schemas.openxmlformats.org/drawingml/2006/main">
               <a:ext uri="{FF2B5EF4-FFF2-40B4-BE49-F238E27FC236}">
-                <a16:creationId xmlns:a16="http://schemas.microsoft.com/office/drawing/2014/main" id="{94BC9EBD-4EAC-4DF6-A4D9-C15896F1BC55}"/>
+                <a16:creationId xmlns:a16="http://schemas.microsoft.com/office/drawing/2014/main" id="{7A6EEF78-6915-44CA-87CB-61EFBE54320C}"/>
               </a:ext>
             </a:extLst>
           </p:cNvPr>
@@ -3568,7 +3568,7 @@
           <p:cNvPr id="12" name="Text-Placeholder-16-13">
             <a:extLst xmlns:a="http://schemas.openxmlformats.org/drawingml/2006/main">
               <a:ext uri="{FF2B5EF4-FFF2-40B4-BE49-F238E27FC236}">
-                <a16:creationId xmlns:a16="http://schemas.microsoft.com/office/drawing/2014/main" id="{A94B9C18-38C7-4C56-AB73-7F3600A3CB69}"/>
+                <a16:creationId xmlns:a16="http://schemas.microsoft.com/office/drawing/2014/main" id="{A392F88E-9416-43AC-A4B6-E6E6074DAA4D}"/>
               </a:ext>
             </a:extLst>
           </p:cNvPr>
@@ -3626,7 +3626,7 @@
     </p:spTree>
     <p:extLst>
       <p:ext uri="{BB962C8B-B14F-4D97-AF65-F5344CB8AC3E}">
-        <p14:creationId xmlns:p14="http://schemas.microsoft.com/office/powerpoint/2010/main" val="1368129579"/>
+        <p14:creationId xmlns:p14="http://schemas.microsoft.com/office/powerpoint/2010/main" val="733792251"/>
       </p:ext>
     </p:extLst>
   </p:cSld>
@@ -3650,7 +3650,7 @@
           <p:cNvPr id="7" name="Slide-Number-Placeholder-1-2">
             <a:extLst xmlns:a="http://schemas.openxmlformats.org/drawingml/2006/main">
               <a:ext uri="{FF2B5EF4-FFF2-40B4-BE49-F238E27FC236}">
-                <a16:creationId xmlns:a16="http://schemas.microsoft.com/office/drawing/2014/main" id="{EF6E8679-A79C-4AD9-869A-DA2917A9429C}"/>
+                <a16:creationId xmlns:a16="http://schemas.microsoft.com/office/drawing/2014/main" id="{5981C0B4-2FD5-4164-A911-1315851CBCFF}"/>
               </a:ext>
             </a:extLst>
           </p:cNvPr>
@@ -3693,7 +3693,7 @@
           <p:cNvPr id="2" name="Title-2-3">
             <a:extLst xmlns:a="http://schemas.openxmlformats.org/drawingml/2006/main">
               <a:ext uri="{FF2B5EF4-FFF2-40B4-BE49-F238E27FC236}">
-                <a16:creationId xmlns:a16="http://schemas.microsoft.com/office/drawing/2014/main" id="{9D4CAA4F-4802-455F-9F7C-CDBDBC8A1996}"/>
+                <a16:creationId xmlns:a16="http://schemas.microsoft.com/office/drawing/2014/main" id="{90E95254-39A0-4AF0-B832-6C161DBEE012}"/>
               </a:ext>
             </a:extLst>
           </p:cNvPr>
@@ -3738,7 +3738,7 @@
           <p:cNvPr id="3" name="Content-Placeholder-9-4">
             <a:extLst xmlns:a="http://schemas.openxmlformats.org/drawingml/2006/main">
               <a:ext uri="{FF2B5EF4-FFF2-40B4-BE49-F238E27FC236}">
-                <a16:creationId xmlns:a16="http://schemas.microsoft.com/office/drawing/2014/main" id="{DEC806D9-A508-4FF4-BDEE-7EDF8FC8503F}"/>
+                <a16:creationId xmlns:a16="http://schemas.microsoft.com/office/drawing/2014/main" id="{F5871DB1-4726-4F66-ABEC-DF949DCA661E}"/>
               </a:ext>
             </a:extLst>
           </p:cNvPr>
@@ -3796,7 +3796,7 @@
           <p:cNvPr id="4" name="Content-Placeholder-10-5">
             <a:extLst xmlns:a="http://schemas.openxmlformats.org/drawingml/2006/main">
               <a:ext uri="{FF2B5EF4-FFF2-40B4-BE49-F238E27FC236}">
-                <a16:creationId xmlns:a16="http://schemas.microsoft.com/office/drawing/2014/main" id="{300EE250-EAF3-4D93-8DB3-4983CA75979B}"/>
+                <a16:creationId xmlns:a16="http://schemas.microsoft.com/office/drawing/2014/main" id="{07BA0433-A210-4ACA-8590-6B23945E415B}"/>
               </a:ext>
             </a:extLst>
           </p:cNvPr>
@@ -3854,7 +3854,7 @@
           <p:cNvPr id="5" name="Content-Placeholder-9-6">
             <a:extLst xmlns:a="http://schemas.openxmlformats.org/drawingml/2006/main">
               <a:ext uri="{FF2B5EF4-FFF2-40B4-BE49-F238E27FC236}">
-                <a16:creationId xmlns:a16="http://schemas.microsoft.com/office/drawing/2014/main" id="{2DA94D83-71B2-41A7-9C00-728F8163B52A}"/>
+                <a16:creationId xmlns:a16="http://schemas.microsoft.com/office/drawing/2014/main" id="{989303D3-474C-4DE8-921F-E4475BF9475C}"/>
               </a:ext>
             </a:extLst>
           </p:cNvPr>
@@ -3914,7 +3914,7 @@
           <p:cNvPr id="6" name="Content-Placeholder-10-7">
             <a:extLst xmlns:a="http://schemas.openxmlformats.org/drawingml/2006/main">
               <a:ext uri="{FF2B5EF4-FFF2-40B4-BE49-F238E27FC236}">
-                <a16:creationId xmlns:a16="http://schemas.microsoft.com/office/drawing/2014/main" id="{882FE8AA-8024-4FBA-8D6B-C956E52C93F8}"/>
+                <a16:creationId xmlns:a16="http://schemas.microsoft.com/office/drawing/2014/main" id="{CEB2C18F-4651-4189-A405-4ED8E6D10C7E}"/>
               </a:ext>
             </a:extLst>
           </p:cNvPr>
@@ -3972,7 +3972,7 @@
     </p:spTree>
     <p:extLst>
       <p:ext uri="{BB962C8B-B14F-4D97-AF65-F5344CB8AC3E}">
-        <p14:creationId xmlns:p14="http://schemas.microsoft.com/office/powerpoint/2010/main" val="1636160049"/>
+        <p14:creationId xmlns:p14="http://schemas.microsoft.com/office/powerpoint/2010/main" val="724600574"/>
       </p:ext>
     </p:extLst>
   </p:cSld>
@@ -3996,7 +3996,7 @@
           <p:cNvPr id="13" name="Rounded-Rectangle-5-1">
             <a:extLst xmlns:a="http://schemas.openxmlformats.org/drawingml/2006/main">
               <a:ext uri="{FF2B5EF4-FFF2-40B4-BE49-F238E27FC236}">
-                <a16:creationId xmlns:a16="http://schemas.microsoft.com/office/drawing/2014/main" id="{B8FA6E3A-1503-4956-8DCA-463FAFC4DEA3}"/>
+                <a16:creationId xmlns:a16="http://schemas.microsoft.com/office/drawing/2014/main" id="{A809C3E0-FD96-458E-AE63-0AFD3B739A61}"/>
               </a:ext>
             </a:extLst>
           </p:cNvPr>
@@ -4025,7 +4025,7 @@
           <p:cNvPr id="2" name="Rounded-Rectangle-6-2">
             <a:extLst xmlns:a="http://schemas.openxmlformats.org/drawingml/2006/main">
               <a:ext uri="{FF2B5EF4-FFF2-40B4-BE49-F238E27FC236}">
-                <a16:creationId xmlns:a16="http://schemas.microsoft.com/office/drawing/2014/main" id="{F084BA5C-2251-4D4D-A0CE-6013D9510637}"/>
+                <a16:creationId xmlns:a16="http://schemas.microsoft.com/office/drawing/2014/main" id="{B41E8481-3CDB-42A2-919B-F07EEA0CC3AD}"/>
               </a:ext>
             </a:extLst>
           </p:cNvPr>
@@ -4054,7 +4054,7 @@
           <p:cNvPr id="3" name="Rounded-Rectangle-7-3">
             <a:extLst xmlns:a="http://schemas.openxmlformats.org/drawingml/2006/main">
               <a:ext uri="{FF2B5EF4-FFF2-40B4-BE49-F238E27FC236}">
-                <a16:creationId xmlns:a16="http://schemas.microsoft.com/office/drawing/2014/main" id="{8A106239-234D-49A5-8A9F-3C0AB7F0C7B7}"/>
+                <a16:creationId xmlns:a16="http://schemas.microsoft.com/office/drawing/2014/main" id="{61664E0A-043B-4D1E-AF5E-F21CA408CD80}"/>
               </a:ext>
             </a:extLst>
           </p:cNvPr>
@@ -4083,7 +4083,7 @@
           <p:cNvPr id="4" name="Slide-Number-Placeholder-1-4">
             <a:extLst xmlns:a="http://schemas.openxmlformats.org/drawingml/2006/main">
               <a:ext uri="{FF2B5EF4-FFF2-40B4-BE49-F238E27FC236}">
-                <a16:creationId xmlns:a16="http://schemas.microsoft.com/office/drawing/2014/main" id="{D1B6EB98-30FB-4C40-8724-A5C73B782908}"/>
+                <a16:creationId xmlns:a16="http://schemas.microsoft.com/office/drawing/2014/main" id="{5ADCEA1B-39D5-4BE6-8F3F-4908854DDDDB}"/>
               </a:ext>
             </a:extLst>
           </p:cNvPr>
@@ -4126,7 +4126,7 @@
           <p:cNvPr id="5" name="Title-2-5">
             <a:extLst xmlns:a="http://schemas.openxmlformats.org/drawingml/2006/main">
               <a:ext uri="{FF2B5EF4-FFF2-40B4-BE49-F238E27FC236}">
-                <a16:creationId xmlns:a16="http://schemas.microsoft.com/office/drawing/2014/main" id="{E5A0EA7B-A95A-4D83-ACA6-293F4E937D9A}"/>
+                <a16:creationId xmlns:a16="http://schemas.microsoft.com/office/drawing/2014/main" id="{79CEC547-EBF4-4A43-9F63-E466AAA1C3C2}"/>
               </a:ext>
             </a:extLst>
           </p:cNvPr>
@@ -4171,7 +4171,7 @@
           <p:cNvPr id="6" name="Content-Placeholder-9-6">
             <a:extLst xmlns:a="http://schemas.openxmlformats.org/drawingml/2006/main">
               <a:ext uri="{FF2B5EF4-FFF2-40B4-BE49-F238E27FC236}">
-                <a16:creationId xmlns:a16="http://schemas.microsoft.com/office/drawing/2014/main" id="{388B1DB9-FDE7-4B12-91E5-9588A9DB8C9E}"/>
+                <a16:creationId xmlns:a16="http://schemas.microsoft.com/office/drawing/2014/main" id="{0CAE42D1-5E63-4C91-95B1-62536CF8E1D3}"/>
               </a:ext>
             </a:extLst>
           </p:cNvPr>
@@ -4216,7 +4216,7 @@
           <p:cNvPr id="7" name="Content-Placeholder-10-7">
             <a:extLst xmlns:a="http://schemas.openxmlformats.org/drawingml/2006/main">
               <a:ext uri="{FF2B5EF4-FFF2-40B4-BE49-F238E27FC236}">
-                <a16:creationId xmlns:a16="http://schemas.microsoft.com/office/drawing/2014/main" id="{2B25F5FB-1D87-4E73-A946-B56A367BB94C}"/>
+                <a16:creationId xmlns:a16="http://schemas.microsoft.com/office/drawing/2014/main" id="{E0B6963C-090D-46D9-BAF0-62F9970DA231}"/>
               </a:ext>
             </a:extLst>
           </p:cNvPr>
@@ -4261,7 +4261,7 @@
           <p:cNvPr id="8" name="Content-Placeholder-11-8">
             <a:extLst xmlns:a="http://schemas.openxmlformats.org/drawingml/2006/main">
               <a:ext uri="{FF2B5EF4-FFF2-40B4-BE49-F238E27FC236}">
-                <a16:creationId xmlns:a16="http://schemas.microsoft.com/office/drawing/2014/main" id="{CB332C4A-5A70-4314-9E40-05951CDC7675}"/>
+                <a16:creationId xmlns:a16="http://schemas.microsoft.com/office/drawing/2014/main" id="{BE8DC223-20F8-4DB2-A627-D8E900F2FFC6}"/>
               </a:ext>
             </a:extLst>
           </p:cNvPr>
@@ -4306,7 +4306,7 @@
           <p:cNvPr id="9" name="Content-Placeholder-9-9">
             <a:extLst xmlns:a="http://schemas.openxmlformats.org/drawingml/2006/main">
               <a:ext uri="{FF2B5EF4-FFF2-40B4-BE49-F238E27FC236}">
-                <a16:creationId xmlns:a16="http://schemas.microsoft.com/office/drawing/2014/main" id="{32628392-1A35-414F-BB19-3EAC3DFA9FBE}"/>
+                <a16:creationId xmlns:a16="http://schemas.microsoft.com/office/drawing/2014/main" id="{5A316FF4-0FB4-4F63-A06C-9D04C5606694}"/>
               </a:ext>
             </a:extLst>
           </p:cNvPr>
@@ -4351,7 +4351,7 @@
           <p:cNvPr id="10" name="Content-Placeholder-9-10">
             <a:extLst xmlns:a="http://schemas.openxmlformats.org/drawingml/2006/main">
               <a:ext uri="{FF2B5EF4-FFF2-40B4-BE49-F238E27FC236}">
-                <a16:creationId xmlns:a16="http://schemas.microsoft.com/office/drawing/2014/main" id="{54355B2C-BBC8-4061-96DD-96DC31779F47}"/>
+                <a16:creationId xmlns:a16="http://schemas.microsoft.com/office/drawing/2014/main" id="{1F608670-D42D-48CD-A5FE-846E666233EF}"/>
               </a:ext>
             </a:extLst>
           </p:cNvPr>
@@ -4396,7 +4396,7 @@
           <p:cNvPr id="11" name="Content-Placeholder-9-11">
             <a:extLst xmlns:a="http://schemas.openxmlformats.org/drawingml/2006/main">
               <a:ext uri="{FF2B5EF4-FFF2-40B4-BE49-F238E27FC236}">
-                <a16:creationId xmlns:a16="http://schemas.microsoft.com/office/drawing/2014/main" id="{5B71E442-845E-4E31-92BF-A7A2E4031156}"/>
+                <a16:creationId xmlns:a16="http://schemas.microsoft.com/office/drawing/2014/main" id="{66D11612-1AB2-44EE-AF66-10C8E02D6EC2}"/>
               </a:ext>
             </a:extLst>
           </p:cNvPr>
@@ -4441,7 +4441,7 @@
           <p:cNvPr id="12" name="Content-Placeholder-15-12">
             <a:extLst xmlns:a="http://schemas.openxmlformats.org/drawingml/2006/main">
               <a:ext uri="{FF2B5EF4-FFF2-40B4-BE49-F238E27FC236}">
-                <a16:creationId xmlns:a16="http://schemas.microsoft.com/office/drawing/2014/main" id="{ECFDAD5D-9BE3-44E8-A0FC-426828647443}"/>
+                <a16:creationId xmlns:a16="http://schemas.microsoft.com/office/drawing/2014/main" id="{3E354EA5-38FE-4A68-8101-8522DA4278BC}"/>
               </a:ext>
             </a:extLst>
           </p:cNvPr>
@@ -4499,7 +4499,7 @@
     </p:spTree>
     <p:extLst>
       <p:ext uri="{BB962C8B-B14F-4D97-AF65-F5344CB8AC3E}">
-        <p14:creationId xmlns:p14="http://schemas.microsoft.com/office/powerpoint/2010/main" val="1416802504"/>
+        <p14:creationId xmlns:p14="http://schemas.microsoft.com/office/powerpoint/2010/main" val="1239153042"/>
       </p:ext>
     </p:extLst>
   </p:cSld>
@@ -4523,7 +4523,7 @@
           <p:cNvPr id="9" name="Google-Shape-532-p58-2">
             <a:extLst xmlns:a="http://schemas.openxmlformats.org/drawingml/2006/main">
               <a:ext uri="{FF2B5EF4-FFF2-40B4-BE49-F238E27FC236}">
-                <a16:creationId xmlns:a16="http://schemas.microsoft.com/office/drawing/2014/main" id="{905BD1ED-5788-4077-A6E0-5CFDFE7EAAB1}"/>
+                <a16:creationId xmlns:a16="http://schemas.microsoft.com/office/drawing/2014/main" id="{119A9FD7-8EA9-4B13-ADCA-95F664FA73A4}"/>
               </a:ext>
             </a:extLst>
           </p:cNvPr>
@@ -4568,7 +4568,7 @@
           <p:cNvPr id="2" name="Google-Shape-533-p58-3">
             <a:extLst xmlns:a="http://schemas.openxmlformats.org/drawingml/2006/main">
               <a:ext uri="{FF2B5EF4-FFF2-40B4-BE49-F238E27FC236}">
-                <a16:creationId xmlns:a16="http://schemas.microsoft.com/office/drawing/2014/main" id="{F8E08EEA-2505-403F-9173-F118332A58BD}"/>
+                <a16:creationId xmlns:a16="http://schemas.microsoft.com/office/drawing/2014/main" id="{BE0C346C-7319-4518-A939-BC8D01D795D3}"/>
               </a:ext>
             </a:extLst>
           </p:cNvPr>
@@ -4613,7 +4613,7 @@
           <p:cNvPr id="3" name="Picture-3-4-backing">
             <a:extLst xmlns:a="http://schemas.openxmlformats.org/drawingml/2006/main">
               <a:ext uri="{FF2B5EF4-FFF2-40B4-BE49-F238E27FC236}">
-                <a16:creationId xmlns:a16="http://schemas.microsoft.com/office/drawing/2014/main" id="{EEF866E9-18B3-4FE4-9A8B-D276A428494A}"/>
+                <a16:creationId xmlns:a16="http://schemas.microsoft.com/office/drawing/2014/main" id="{87C32076-E91A-4D9E-A476-683CE948EC5E}"/>
               </a:ext>
             </a:extLst>
           </p:cNvPr>
@@ -4648,7 +4648,7 @@
           <p:cNvPr id="5" name="Google-Shape-534-p58-5">
             <a:extLst xmlns:a="http://schemas.openxmlformats.org/drawingml/2006/main">
               <a:ext uri="{FF2B5EF4-FFF2-40B4-BE49-F238E27FC236}">
-                <a16:creationId xmlns:a16="http://schemas.microsoft.com/office/drawing/2014/main" id="{CC660099-9409-49F2-BEC2-70789DED8742}"/>
+                <a16:creationId xmlns:a16="http://schemas.microsoft.com/office/drawing/2014/main" id="{4D677260-68A0-4807-8662-F54D430E6B34}"/>
               </a:ext>
             </a:extLst>
           </p:cNvPr>
@@ -4708,7 +4708,7 @@
           <p:cNvPr id="6" name="proof-copy">
             <a:extLst xmlns:a="http://schemas.openxmlformats.org/drawingml/2006/main">
               <a:ext uri="{FF2B5EF4-FFF2-40B4-BE49-F238E27FC236}">
-                <a16:creationId xmlns:a16="http://schemas.microsoft.com/office/drawing/2014/main" id="{6F99F693-1E72-43AE-AF93-242F1F530637}"/>
+                <a16:creationId xmlns:a16="http://schemas.microsoft.com/office/drawing/2014/main" id="{ED86BAC8-D91C-4A9D-B70A-3E6E7FADEF8A}"/>
               </a:ext>
             </a:extLst>
           </p:cNvPr>
@@ -4764,7 +4764,7 @@
           <p:cNvPr id="7" name="proof-detail">
             <a:extLst xmlns:a="http://schemas.openxmlformats.org/drawingml/2006/main">
               <a:ext uri="{FF2B5EF4-FFF2-40B4-BE49-F238E27FC236}">
-                <a16:creationId xmlns:a16="http://schemas.microsoft.com/office/drawing/2014/main" id="{6CD26ED3-760C-4851-8345-D4D9FB4728D6}"/>
+                <a16:creationId xmlns:a16="http://schemas.microsoft.com/office/drawing/2014/main" id="{CC0E03FB-1A62-4716-A991-812B19576E48}"/>
               </a:ext>
             </a:extLst>
           </p:cNvPr>
@@ -4824,7 +4824,7 @@
           <p:nvPr/>
         </p:nvPicPr>
         <p:blipFill>
-          <a:blip xmlns:r="http://schemas.openxmlformats.org/officeDocument/2006/relationships" xmlns:a="http://schemas.openxmlformats.org/drawingml/2006/main" r:embed="R245e44b239ed493e"/>
+          <a:blip xmlns:r="http://schemas.openxmlformats.org/officeDocument/2006/relationships" xmlns:a="http://schemas.openxmlformats.org/drawingml/2006/main" r:embed="R6510f6bbbe3d4f64"/>
           <a:stretch xmlns:a="http://schemas.openxmlformats.org/drawingml/2006/main"/>
         </p:blipFill>
         <p:spPr>
@@ -4842,7 +4842,7 @@
     </p:spTree>
     <p:extLst>
       <p:ext uri="{BB962C8B-B14F-4D97-AF65-F5344CB8AC3E}">
-        <p14:creationId xmlns:p14="http://schemas.microsoft.com/office/powerpoint/2010/main" val="1478131419"/>
+        <p14:creationId xmlns:p14="http://schemas.microsoft.com/office/powerpoint/2010/main" val="1956413228"/>
       </p:ext>
     </p:extLst>
   </p:cSld>
@@ -4866,7 +4866,7 @@
           <p:cNvPr id="17" name="Google-Shape-532-p58-2">
             <a:extLst xmlns:a="http://schemas.openxmlformats.org/drawingml/2006/main">
               <a:ext uri="{FF2B5EF4-FFF2-40B4-BE49-F238E27FC236}">
-                <a16:creationId xmlns:a16="http://schemas.microsoft.com/office/drawing/2014/main" id="{8080B744-5579-4A5D-A07A-DDD91274CC98}"/>
+                <a16:creationId xmlns:a16="http://schemas.microsoft.com/office/drawing/2014/main" id="{D0B1D071-229C-4489-98A1-E9EAAB9032E3}"/>
               </a:ext>
             </a:extLst>
           </p:cNvPr>
@@ -4911,7 +4911,7 @@
           <p:cNvPr id="2" name="Google-Shape-533-p58-3">
             <a:extLst xmlns:a="http://schemas.openxmlformats.org/drawingml/2006/main">
               <a:ext uri="{FF2B5EF4-FFF2-40B4-BE49-F238E27FC236}">
-                <a16:creationId xmlns:a16="http://schemas.microsoft.com/office/drawing/2014/main" id="{45D91513-D8DC-46C4-9CB1-4A87399A1630}"/>
+                <a16:creationId xmlns:a16="http://schemas.microsoft.com/office/drawing/2014/main" id="{838F2209-7778-4BC6-9B9F-F0FEEB3CFFDC}"/>
               </a:ext>
             </a:extLst>
           </p:cNvPr>
@@ -5043,7 +5043,7 @@
           <p:cNvPr id="4" name="Google-Shape-955-p80-5">
             <a:extLst xmlns:a="http://schemas.openxmlformats.org/drawingml/2006/main">
               <a:ext uri="{FF2B5EF4-FFF2-40B4-BE49-F238E27FC236}">
-                <a16:creationId xmlns:a16="http://schemas.microsoft.com/office/drawing/2014/main" id="{526DA92E-7CCD-4BB1-982C-FFE036F5E92F}"/>
+                <a16:creationId xmlns:a16="http://schemas.microsoft.com/office/drawing/2014/main" id="{284F8F73-559E-484A-A70D-2B0AA148C6CA}"/>
               </a:ext>
             </a:extLst>
           </p:cNvPr>
@@ -5072,7 +5072,7 @@
           <p:cNvPr id="5" name="Google-Shape-955-p80-5">
             <a:extLst xmlns:a="http://schemas.openxmlformats.org/drawingml/2006/main">
               <a:ext uri="{FF2B5EF4-FFF2-40B4-BE49-F238E27FC236}">
-                <a16:creationId xmlns:a16="http://schemas.microsoft.com/office/drawing/2014/main" id="{D14F2A17-AAE7-4F91-ADCE-DAA84344A4F2}"/>
+                <a16:creationId xmlns:a16="http://schemas.microsoft.com/office/drawing/2014/main" id="{EF55A755-D1E2-4880-A713-3A0ADC27DCC6}"/>
               </a:ext>
             </a:extLst>
           </p:cNvPr>
@@ -5117,7 +5117,7 @@
           <p:cNvPr id="6" name="Google-Shape-957-p80-6">
             <a:extLst xmlns:a="http://schemas.openxmlformats.org/drawingml/2006/main">
               <a:ext uri="{FF2B5EF4-FFF2-40B4-BE49-F238E27FC236}">
-                <a16:creationId xmlns:a16="http://schemas.microsoft.com/office/drawing/2014/main" id="{CDC8E86F-3922-49FC-A592-3C583A01F891}"/>
+                <a16:creationId xmlns:a16="http://schemas.microsoft.com/office/drawing/2014/main" id="{426600F1-CD5C-4033-ADF3-0EBC726072EE}"/>
               </a:ext>
             </a:extLst>
           </p:cNvPr>
@@ -5146,7 +5146,7 @@
           <p:cNvPr id="7" name="Google-Shape-957-p80-6">
             <a:extLst xmlns:a="http://schemas.openxmlformats.org/drawingml/2006/main">
               <a:ext uri="{FF2B5EF4-FFF2-40B4-BE49-F238E27FC236}">
-                <a16:creationId xmlns:a16="http://schemas.microsoft.com/office/drawing/2014/main" id="{E7495A25-8F96-4AFE-ACE0-6EBA5BB631D9}"/>
+                <a16:creationId xmlns:a16="http://schemas.microsoft.com/office/drawing/2014/main" id="{0F115225-F328-4824-8DD0-F93337B7BBDE}"/>
               </a:ext>
             </a:extLst>
           </p:cNvPr>
@@ -5191,7 +5191,7 @@
           <p:cNvPr id="8" name="Google-Shape-960-p80-7">
             <a:extLst xmlns:a="http://schemas.openxmlformats.org/drawingml/2006/main">
               <a:ext uri="{FF2B5EF4-FFF2-40B4-BE49-F238E27FC236}">
-                <a16:creationId xmlns:a16="http://schemas.microsoft.com/office/drawing/2014/main" id="{DE6AAA71-BD96-41F4-A523-264DEC20C720}"/>
+                <a16:creationId xmlns:a16="http://schemas.microsoft.com/office/drawing/2014/main" id="{C260D794-60F7-42C6-AD9E-6E2E745F9366}"/>
               </a:ext>
             </a:extLst>
           </p:cNvPr>
@@ -5220,7 +5220,7 @@
           <p:cNvPr id="9" name="Google-Shape-960-p80-7">
             <a:extLst xmlns:a="http://schemas.openxmlformats.org/drawingml/2006/main">
               <a:ext uri="{FF2B5EF4-FFF2-40B4-BE49-F238E27FC236}">
-                <a16:creationId xmlns:a16="http://schemas.microsoft.com/office/drawing/2014/main" id="{5BA083A7-7344-4EF4-9141-206C12E9FB46}"/>
+                <a16:creationId xmlns:a16="http://schemas.microsoft.com/office/drawing/2014/main" id="{209938E9-0192-4C6D-9FC8-FADEFAE94715}"/>
               </a:ext>
             </a:extLst>
           </p:cNvPr>
@@ -5265,7 +5265,7 @@
           <p:cNvPr id="10" name="Google-Shape-963-p80-8">
             <a:extLst xmlns:a="http://schemas.openxmlformats.org/drawingml/2006/main">
               <a:ext uri="{FF2B5EF4-FFF2-40B4-BE49-F238E27FC236}">
-                <a16:creationId xmlns:a16="http://schemas.microsoft.com/office/drawing/2014/main" id="{955273BE-955F-449F-A511-6E2E2BE94A19}"/>
+                <a16:creationId xmlns:a16="http://schemas.microsoft.com/office/drawing/2014/main" id="{88BD361F-A424-4FCC-BBDC-269FC96EF024}"/>
               </a:ext>
             </a:extLst>
           </p:cNvPr>
@@ -5294,7 +5294,7 @@
           <p:cNvPr id="11" name="Google-Shape-963-p80-8">
             <a:extLst xmlns:a="http://schemas.openxmlformats.org/drawingml/2006/main">
               <a:ext uri="{FF2B5EF4-FFF2-40B4-BE49-F238E27FC236}">
-                <a16:creationId xmlns:a16="http://schemas.microsoft.com/office/drawing/2014/main" id="{28FF4C50-D2C5-40C8-AAA9-E8E2B5C2FF47}"/>
+                <a16:creationId xmlns:a16="http://schemas.microsoft.com/office/drawing/2014/main" id="{38946D5F-0E41-41AD-A4A3-DE4DE5B336B6}"/>
               </a:ext>
             </a:extLst>
           </p:cNvPr>
@@ -5339,7 +5339,7 @@
           <p:cNvPr id="12" name="Google-Shape-966-p80-9">
             <a:extLst xmlns:a="http://schemas.openxmlformats.org/drawingml/2006/main">
               <a:ext uri="{FF2B5EF4-FFF2-40B4-BE49-F238E27FC236}">
-                <a16:creationId xmlns:a16="http://schemas.microsoft.com/office/drawing/2014/main" id="{3654BB4C-30D9-48E0-A7E5-09F99B0178C5}"/>
+                <a16:creationId xmlns:a16="http://schemas.microsoft.com/office/drawing/2014/main" id="{3633E426-1908-47E2-A67A-94B6D5F486DA}"/>
               </a:ext>
             </a:extLst>
           </p:cNvPr>
@@ -5368,7 +5368,7 @@
           <p:cNvPr id="13" name="Google-Shape-966-p80-9">
             <a:extLst xmlns:a="http://schemas.openxmlformats.org/drawingml/2006/main">
               <a:ext uri="{FF2B5EF4-FFF2-40B4-BE49-F238E27FC236}">
-                <a16:creationId xmlns:a16="http://schemas.microsoft.com/office/drawing/2014/main" id="{B01EEFCA-9425-4FD7-A407-19798CD31A82}"/>
+                <a16:creationId xmlns:a16="http://schemas.microsoft.com/office/drawing/2014/main" id="{A6D50599-5153-4283-B623-00C56ACC37B6}"/>
               </a:ext>
             </a:extLst>
           </p:cNvPr>
@@ -5413,7 +5413,7 @@
           <p:cNvPr id="14" name="Google-Shape-969-p80-10">
             <a:extLst xmlns:a="http://schemas.openxmlformats.org/drawingml/2006/main">
               <a:ext uri="{FF2B5EF4-FFF2-40B4-BE49-F238E27FC236}">
-                <a16:creationId xmlns:a16="http://schemas.microsoft.com/office/drawing/2014/main" id="{345FED60-1CB7-4669-81E3-F7A27F05CB46}"/>
+                <a16:creationId xmlns:a16="http://schemas.microsoft.com/office/drawing/2014/main" id="{CE8FFB28-7356-4D57-99FE-63F4C22910BE}"/>
               </a:ext>
             </a:extLst>
           </p:cNvPr>
@@ -5442,7 +5442,7 @@
           <p:cNvPr id="15" name="Google-Shape-969-p80-10">
             <a:extLst xmlns:a="http://schemas.openxmlformats.org/drawingml/2006/main">
               <a:ext uri="{FF2B5EF4-FFF2-40B4-BE49-F238E27FC236}">
-                <a16:creationId xmlns:a16="http://schemas.microsoft.com/office/drawing/2014/main" id="{47C82B9B-29E6-4165-B5E8-7C81C7DF9A59}"/>
+                <a16:creationId xmlns:a16="http://schemas.microsoft.com/office/drawing/2014/main" id="{30CBEA0F-8536-4BCC-9A98-752FCACA5201}"/>
               </a:ext>
             </a:extLst>
           </p:cNvPr>
@@ -5487,7 +5487,7 @@
           <p:cNvPr id="16" name="live-url">
             <a:extLst xmlns:a="http://schemas.openxmlformats.org/drawingml/2006/main">
               <a:ext uri="{FF2B5EF4-FFF2-40B4-BE49-F238E27FC236}">
-                <a16:creationId xmlns:a16="http://schemas.microsoft.com/office/drawing/2014/main" id="{B041C7F4-E9D8-4F30-BB75-0F752451C463}"/>
+                <a16:creationId xmlns:a16="http://schemas.microsoft.com/office/drawing/2014/main" id="{31C47E3B-55E9-49D6-A3FD-D3AF3A2ECA07}"/>
               </a:ext>
             </a:extLst>
           </p:cNvPr>
@@ -5533,7 +5533,7 @@
                 <a:ea typeface="Helvetica Neue"/>
                 <a:cs typeface="Helvetica Neue"/>
               </a:rPr>
-              <a:t>https://radar-agent-arc-2026.chrischang2026.chatgpt.site</a:t>
+              <a:t>https://radar-agent-arc-2026.chrischang2026.workers.dev</a:t>
             </a:r>
           </a:p>
         </p:txBody>
@@ -5541,7 +5541,7 @@
     </p:spTree>
     <p:extLst>
       <p:ext uri="{BB962C8B-B14F-4D97-AF65-F5344CB8AC3E}">
-        <p14:creationId xmlns:p14="http://schemas.microsoft.com/office/powerpoint/2010/main" val="1379932091"/>
+        <p14:creationId xmlns:p14="http://schemas.microsoft.com/office/powerpoint/2010/main" val="616021555"/>
       </p:ext>
     </p:extLst>
   </p:cSld>
@@ -5565,7 +5565,7 @@
           <p:cNvPr id="4" name="Title-3-1">
             <a:extLst xmlns:a="http://schemas.openxmlformats.org/drawingml/2006/main">
               <a:ext uri="{FF2B5EF4-FFF2-40B4-BE49-F238E27FC236}">
-                <a16:creationId xmlns:a16="http://schemas.microsoft.com/office/drawing/2014/main" id="{B7F65108-4DD7-4CE7-BAA5-88BB82F062F9}"/>
+                <a16:creationId xmlns:a16="http://schemas.microsoft.com/office/drawing/2014/main" id="{B90F0B07-8EB1-4C88-BA80-C28E5F32A5B6}"/>
               </a:ext>
             </a:extLst>
           </p:cNvPr>
@@ -5610,7 +5610,7 @@
           <p:cNvPr id="2" name="Subtitle-4-2">
             <a:extLst xmlns:a="http://schemas.openxmlformats.org/drawingml/2006/main">
               <a:ext uri="{FF2B5EF4-FFF2-40B4-BE49-F238E27FC236}">
-                <a16:creationId xmlns:a16="http://schemas.microsoft.com/office/drawing/2014/main" id="{17D60C5C-173F-4ADD-9BAE-31D75ACFAD4C}"/>
+                <a16:creationId xmlns:a16="http://schemas.microsoft.com/office/drawing/2014/main" id="{C2DB6BFA-C835-4B98-AD03-0C8D140FA0EF}"/>
               </a:ext>
             </a:extLst>
           </p:cNvPr>
@@ -5645,7 +5645,7 @@
               </a:defRPr>
             </a:pPr>
             <a:r>
-              <a:t>Live · radar-agent-arc-2026.chrischang2026.chatgpt.site</a:t>
+              <a:t>Live · radar-agent-arc-2026.chrischang2026.workers.dev</a:t>
             </a:r>
           </a:p>
           <a:p xmlns:a="http://schemas.openxmlformats.org/drawingml/2006/main">
@@ -5685,7 +5685,7 @@
           <p:cNvPr id="3" name="Subtitle-4-3">
             <a:extLst xmlns:a="http://schemas.openxmlformats.org/drawingml/2006/main">
               <a:ext uri="{FF2B5EF4-FFF2-40B4-BE49-F238E27FC236}">
-                <a16:creationId xmlns:a16="http://schemas.microsoft.com/office/drawing/2014/main" id="{0AD2BAB8-FB3C-4681-ACB9-D94ED6F4E2A8}"/>
+                <a16:creationId xmlns:a16="http://schemas.microsoft.com/office/drawing/2014/main" id="{2F240D60-8867-45F9-A6D6-81A2801782A1}"/>
               </a:ext>
             </a:extLst>
           </p:cNvPr>
@@ -5728,7 +5728,7 @@
     </p:spTree>
     <p:extLst>
       <p:ext uri="{BB962C8B-B14F-4D97-AF65-F5344CB8AC3E}">
-        <p14:creationId xmlns:p14="http://schemas.microsoft.com/office/powerpoint/2010/main" val="980377695"/>
+        <p14:creationId xmlns:p14="http://schemas.microsoft.com/office/powerpoint/2010/main" val="1109043491"/>
       </p:ext>
     </p:extLst>
   </p:cSld>

</xml_diff>